<commit_message>
v1.1.1: full-width headlines; fix the four gallery slides flagged by composition
- Headlines run to the right margin instead of being narrowed to "balance"
  lines; a widow is fixed by the smallest narrowing that is widow-free
  across a +/-1.2% renderer tolerance (LibreOffice/PowerPoint wrap
  differently near the edge)
- Process diagrams: per-step metric row; timelines: per-event detail line;
  takeaway columns show their title; Harvey balls in the secondary colour;
  automatic proof ignores forecast periods; hierarchy metric ignores big
  figures; content-scale variants for text diagrams
- Gallery g07/g13/g14/g18/g19: 0 composition warnings (92.1, was 87.0);
  eval suite 84.0, baseline updated; examples regenerated; version 1.1.1

Co-Authored-By: Claude Opus 5.5 <noreply@anthropic.com>
Claude-Session: https://claude.ai/code/session_01Rvc9GtWhuPc2Bv8Fiv99q3
</commit_message>
<xml_diff>
--- a/examples/alvora/output/1_draft/deck.pptx
+++ b/examples/alvora/output/1_draft/deck.pptx
@@ -6444,7 +6444,7 @@
         <p:spPr>
           <a:xfrm>
             <a:off x="502920" y="475488"/>
-            <a:ext cx="8376964" cy="786384"/>
+            <a:ext cx="11185855" cy="786384"/>
           </a:xfrm>
           <a:prstGeom prst="rect">
             <a:avLst/>
@@ -8269,7 +8269,7 @@
         <p:spPr>
           <a:xfrm>
             <a:off x="502920" y="475488"/>
-            <a:ext cx="6635743" cy="786384"/>
+            <a:ext cx="10527487" cy="786384"/>
           </a:xfrm>
           <a:prstGeom prst="rect">
             <a:avLst/>
@@ -10240,7 +10240,7 @@
         <p:spPr>
           <a:xfrm>
             <a:off x="502920" y="475488"/>
-            <a:ext cx="6382527" cy="786384"/>
+            <a:ext cx="10500055" cy="786384"/>
           </a:xfrm>
           <a:prstGeom prst="rect">
             <a:avLst/>
@@ -11909,7 +11909,7 @@
         <p:spPr>
           <a:xfrm>
             <a:off x="502920" y="475488"/>
-            <a:ext cx="6382527" cy="786384"/>
+            <a:ext cx="10417759" cy="786384"/>
           </a:xfrm>
           <a:prstGeom prst="rect">
             <a:avLst/>
@@ -13172,7 +13172,7 @@
         <p:spPr>
           <a:xfrm>
             <a:off x="502920" y="475488"/>
-            <a:ext cx="6382527" cy="786384"/>
+            <a:ext cx="10472623" cy="786384"/>
           </a:xfrm>
           <a:prstGeom prst="rect">
             <a:avLst/>
@@ -18148,7 +18148,7 @@
         <p:spPr>
           <a:xfrm>
             <a:off x="502920" y="475488"/>
-            <a:ext cx="6382527" cy="786384"/>
+            <a:ext cx="10774375" cy="786384"/>
           </a:xfrm>
           <a:prstGeom prst="rect">
             <a:avLst/>
@@ -19272,7 +19272,7 @@
         <p:spPr>
           <a:xfrm>
             <a:off x="502920" y="475488"/>
-            <a:ext cx="6382527" cy="786384"/>
+            <a:ext cx="10445191" cy="786384"/>
           </a:xfrm>
           <a:prstGeom prst="rect">
             <a:avLst/>

</xml_diff>

<commit_message>
v1.2.0: docs, version, holdout findings
Co-Authored-By: Claude Opus 5.5 <noreply@anthropic.com>
Claude-Session: https://claude.ai/code/session_01Rvc9GtWhuPc2Bv8Fiv99q3
</commit_message>
<xml_diff>
--- a/examples/alvora/output/1_draft/deck.pptx
+++ b/examples/alvora/output/1_draft/deck.pptx
@@ -18265,7 +18265,7 @@
         <p:spPr>
           <a:xfrm>
             <a:off x="502920" y="1481328"/>
-            <a:ext cx="11185855" cy="274320"/>
+            <a:ext cx="6441262" cy="274320"/>
           </a:xfrm>
           <a:prstGeom prst="rect">
             <a:avLst/>
@@ -18313,7 +18313,7 @@
         <p:spPr>
           <a:xfrm>
             <a:off x="640080" y="2267712"/>
-            <a:ext cx="5478628" cy="1357884"/>
+            <a:ext cx="3106331" cy="1773936"/>
           </a:xfrm>
           <a:prstGeom prst="rect">
             <a:avLst/>
@@ -18341,8 +18341,8 @@
         </p:nvSpPr>
         <p:spPr>
           <a:xfrm>
-            <a:off x="6118708" y="2267712"/>
-            <a:ext cx="5478628" cy="1357884"/>
+            <a:off x="3746411" y="2267712"/>
+            <a:ext cx="3106331" cy="1773936"/>
           </a:xfrm>
           <a:prstGeom prst="rect">
             <a:avLst/>
@@ -18370,8 +18370,8 @@
         </p:nvSpPr>
         <p:spPr>
           <a:xfrm>
-            <a:off x="640080" y="3625596"/>
-            <a:ext cx="5478628" cy="1357884"/>
+            <a:off x="640080" y="4041648"/>
+            <a:ext cx="3106331" cy="1773936"/>
           </a:xfrm>
           <a:prstGeom prst="rect">
             <a:avLst/>
@@ -18401,8 +18401,8 @@
         </p:nvSpPr>
         <p:spPr>
           <a:xfrm>
-            <a:off x="6118708" y="3625596"/>
-            <a:ext cx="5478628" cy="1357884"/>
+            <a:off x="3746411" y="4041648"/>
+            <a:ext cx="3106331" cy="1773936"/>
           </a:xfrm>
           <a:prstGeom prst="rect">
             <a:avLst/>
@@ -18431,7 +18431,7 @@
         <p:spPr>
           <a:xfrm>
             <a:off x="731520" y="2340864"/>
-            <a:ext cx="5295748" cy="237744"/>
+            <a:ext cx="2923451" cy="237744"/>
           </a:xfrm>
           <a:prstGeom prst="rect">
             <a:avLst/>
@@ -18469,8 +18469,8 @@
         </p:nvSpPr>
         <p:spPr>
           <a:xfrm>
-            <a:off x="6210148" y="2340864"/>
-            <a:ext cx="5295748" cy="237744"/>
+            <a:off x="3837851" y="2340864"/>
+            <a:ext cx="2923451" cy="237744"/>
           </a:xfrm>
           <a:prstGeom prst="rect">
             <a:avLst/>
@@ -18508,8 +18508,8 @@
         </p:nvSpPr>
         <p:spPr>
           <a:xfrm>
-            <a:off x="731520" y="4672584"/>
-            <a:ext cx="5295748" cy="237744"/>
+            <a:off x="731520" y="5504688"/>
+            <a:ext cx="2923451" cy="237744"/>
           </a:xfrm>
           <a:prstGeom prst="rect">
             <a:avLst/>
@@ -18547,8 +18547,8 @@
         </p:nvSpPr>
         <p:spPr>
           <a:xfrm>
-            <a:off x="6210148" y="4672584"/>
-            <a:ext cx="5295748" cy="237744"/>
+            <a:off x="3837851" y="5504688"/>
+            <a:ext cx="2923451" cy="237744"/>
           </a:xfrm>
           <a:prstGeom prst="rect">
             <a:avLst/>
@@ -18586,8 +18586,8 @@
         </p:nvCxnSpPr>
         <p:spPr>
           <a:xfrm>
-            <a:off x="640080" y="4983480"/>
-            <a:ext cx="11002975" cy="0"/>
+            <a:off x="640080" y="5815584"/>
+            <a:ext cx="6258382" cy="0"/>
           </a:xfrm>
           <a:prstGeom prst="line">
             <a:avLst/>
@@ -18609,7 +18609,7 @@
         <p:spPr>
           <a:xfrm flipV="1">
             <a:off x="640080" y="2221992"/>
-            <a:ext cx="0" cy="2761488"/>
+            <a:ext cx="0" cy="3593592"/>
           </a:xfrm>
           <a:prstGeom prst="line">
             <a:avLst/>
@@ -18630,8 +18630,8 @@
         </p:nvSpPr>
         <p:spPr>
           <a:xfrm>
-            <a:off x="640080" y="5038344"/>
-            <a:ext cx="10957255" cy="274320"/>
+            <a:off x="640080" y="5870448"/>
+            <a:ext cx="6212662" cy="274320"/>
           </a:xfrm>
           <a:prstGeom prst="rect">
             <a:avLst/>
@@ -18708,8 +18708,8 @@
         </p:nvSpPr>
         <p:spPr>
           <a:xfrm>
-            <a:off x="6778027" y="3055285"/>
-            <a:ext cx="434523" cy="434523"/>
+            <a:off x="3959594" y="3296595"/>
+            <a:ext cx="567660" cy="567660"/>
           </a:xfrm>
           <a:prstGeom prst="ellipse">
             <a:avLst/>
@@ -18739,7 +18739,7 @@
         </p:nvSpPr>
         <p:spPr>
           <a:xfrm>
-            <a:off x="7249125" y="3162818"/>
+            <a:off x="4563830" y="3470697"/>
             <a:ext cx="814217" cy="219456"/>
           </a:xfrm>
           <a:prstGeom prst="rect">
@@ -18778,8 +18778,8 @@
         </p:nvSpPr>
         <p:spPr>
           <a:xfrm>
-            <a:off x="9857271" y="3854071"/>
-            <a:ext cx="412097" cy="412097"/>
+            <a:off x="5713789" y="4340127"/>
+            <a:ext cx="538362" cy="538362"/>
           </a:xfrm>
           <a:prstGeom prst="ellipse">
             <a:avLst/>
@@ -18809,7 +18809,7 @@
         </p:nvSpPr>
         <p:spPr>
           <a:xfrm>
-            <a:off x="10305944" y="3950391"/>
+            <a:off x="4870001" y="4499580"/>
             <a:ext cx="807212" cy="219456"/>
           </a:xfrm>
           <a:prstGeom prst="rect">
@@ -18848,8 +18848,8 @@
         </p:nvSpPr>
         <p:spPr>
           <a:xfrm>
-            <a:off x="3727050" y="2773605"/>
-            <a:ext cx="400413" cy="400413"/>
+            <a:off x="2242330" y="2928610"/>
+            <a:ext cx="523098" cy="523098"/>
           </a:xfrm>
           <a:prstGeom prst="ellipse">
             <a:avLst/>
@@ -18879,7 +18879,7 @@
         </p:nvSpPr>
         <p:spPr>
           <a:xfrm>
-            <a:off x="4164039" y="2864084"/>
+            <a:off x="2802004" y="3080431"/>
             <a:ext cx="821222" cy="219456"/>
           </a:xfrm>
           <a:prstGeom prst="rect">
@@ -18918,8 +18918,8 @@
         </p:nvSpPr>
         <p:spPr>
           <a:xfrm>
-            <a:off x="4833606" y="3599166"/>
-            <a:ext cx="378753" cy="378753"/>
+            <a:off x="2877744" y="4007120"/>
+            <a:ext cx="494801" cy="494801"/>
           </a:xfrm>
           <a:prstGeom prst="ellipse">
             <a:avLst/>
@@ -18949,7 +18949,7 @@
         </p:nvSpPr>
         <p:spPr>
           <a:xfrm>
-            <a:off x="5248934" y="3678814"/>
+            <a:off x="3409122" y="4144792"/>
             <a:ext cx="433118" cy="219456"/>
           </a:xfrm>
           <a:prstGeom prst="rect">
@@ -18988,8 +18988,8 @@
         </p:nvSpPr>
         <p:spPr>
           <a:xfrm>
-            <a:off x="7746083" y="2630764"/>
-            <a:ext cx="251572" cy="251572"/>
+            <a:off x="4576111" y="2742003"/>
+            <a:ext cx="328653" cy="328653"/>
           </a:xfrm>
           <a:prstGeom prst="ellipse">
             <a:avLst/>
@@ -19019,7 +19019,7 @@
         </p:nvSpPr>
         <p:spPr>
           <a:xfrm>
-            <a:off x="8034230" y="2646822"/>
+            <a:off x="4941339" y="2796601"/>
             <a:ext cx="1181346" cy="219456"/>
           </a:xfrm>
           <a:prstGeom prst="rect">
@@ -19058,8 +19058,8 @@
         </p:nvCxnSpPr>
         <p:spPr>
           <a:xfrm>
-            <a:off x="502920" y="5568696"/>
-            <a:ext cx="11185855" cy="0"/>
+            <a:off x="7145350" y="1481328"/>
+            <a:ext cx="0" cy="4718304"/>
           </a:xfrm>
           <a:prstGeom prst="line">
             <a:avLst/>
@@ -19079,8 +19079,8 @@
         </p:nvSpPr>
         <p:spPr>
           <a:xfrm>
-            <a:off x="502920" y="5705856"/>
-            <a:ext cx="3594506" cy="493776"/>
+            <a:off x="7373950" y="1481328"/>
+            <a:ext cx="4314825" cy="4718304"/>
           </a:xfrm>
           <a:prstGeom prst="rect">
             <a:avLst/>
@@ -19093,10 +19093,19 @@
           </a:bodyPr>
           <a:lstStyle/>
           <a:p>
-            <a:pPr algn="l">
+            <a:pPr algn="l" marL="155448" indent="-155448">
               <a:lnSpc>
-                <a:spcPct val="100000"/>
+                <a:spcPct val="108000"/>
               </a:lnSpc>
+              <a:spcAft>
+                <a:spcPts val="800"/>
+              </a:spcAft>
+              <a:buClr>
+                <a:srgbClr val="1E252D"/>
+              </a:buClr>
+              <a:buSzPct val="100000"/>
+              <a:buFont typeface="Arial"/>
+              <a:buChar char="•"/>
             </a:pPr>
             <a:r>
               <a:rPr sz="1200" b="0">
@@ -19126,34 +19135,20 @@
               <a:t> Competitor A on a comparable basket</a:t>
             </a:r>
           </a:p>
-        </p:txBody>
-      </p:sp>
-      <p:sp>
-        <p:nvSpPr>
-          <p:cNvPr id="31" name="cpe|commentary|text|30"/>
-          <p:cNvSpPr txBox="1"/>
-          <p:nvPr/>
-        </p:nvSpPr>
-        <p:spPr>
-          <a:xfrm>
-            <a:off x="4298594" y="5705856"/>
-            <a:ext cx="3594506" cy="493776"/>
-          </a:xfrm>
-          <a:prstGeom prst="rect">
-            <a:avLst/>
-          </a:prstGeom>
-          <a:noFill/>
-        </p:spPr>
-        <p:txBody>
-          <a:bodyPr wrap="square" lIns="0" rIns="0" tIns="0" bIns="0" anchor="t">
-            <a:noAutofit/>
-          </a:bodyPr>
-          <a:lstStyle/>
-          <a:p>
-            <a:pPr algn="l">
+          <a:p>
+            <a:pPr algn="l" marL="155448" indent="-155448">
               <a:lnSpc>
-                <a:spcPct val="100000"/>
+                <a:spcPct val="108000"/>
               </a:lnSpc>
+              <a:spcAft>
+                <a:spcPts val="800"/>
+              </a:spcAft>
+              <a:buClr>
+                <a:srgbClr val="1E252D"/>
+              </a:buClr>
+              <a:buSzPct val="100000"/>
+              <a:buFont typeface="Arial"/>
+              <a:buChar char="•"/>
             </a:pPr>
             <a:r>
               <a:rPr sz="1200" b="0">
@@ -19165,34 +19160,17 @@
               <a:t>Its experience score trails B and C on freshness and queues</a:t>
             </a:r>
           </a:p>
-        </p:txBody>
-      </p:sp>
-      <p:sp>
-        <p:nvSpPr>
-          <p:cNvPr id="32" name="cpe|commentary|text|31"/>
-          <p:cNvSpPr txBox="1"/>
-          <p:nvPr/>
-        </p:nvSpPr>
-        <p:spPr>
-          <a:xfrm>
-            <a:off x="8094269" y="5705856"/>
-            <a:ext cx="3594506" cy="493776"/>
-          </a:xfrm>
-          <a:prstGeom prst="rect">
-            <a:avLst/>
-          </a:prstGeom>
-          <a:noFill/>
-        </p:spPr>
-        <p:txBody>
-          <a:bodyPr wrap="square" lIns="0" rIns="0" tIns="0" bIns="0" anchor="t">
-            <a:noAutofit/>
-          </a:bodyPr>
-          <a:lstStyle/>
-          <a:p>
-            <a:pPr algn="l">
+          <a:p>
+            <a:pPr algn="l" marL="155448" indent="-155448">
               <a:lnSpc>
-                <a:spcPct val="100000"/>
+                <a:spcPct val="108000"/>
               </a:lnSpc>
+              <a:buClr>
+                <a:srgbClr val="1E252D"/>
+              </a:buClr>
+              <a:buSzPct val="100000"/>
+              <a:buFont typeface="Arial"/>
+              <a:buChar char="•"/>
             </a:pPr>
             <a:r>
               <a:rPr sz="1200" b="0">

</xml_diff>

<commit_message>
v1.3.1: centred agenda and statement blocks, middle-anchored executive summary rows
Co-Authored-By: Claude Opus 5.5 <noreply@anthropic.com>
Claude-Session: https://claude.ai/code/session_01Rvc9GtWhuPc2Bv8Fiv99q3
</commit_message>
<xml_diff>
--- a/examples/alvora/output/1_draft/deck.pptx
+++ b/examples/alvora/output/1_draft/deck.pptx
@@ -10357,7 +10357,7 @@
         <p:spPr>
           <a:xfrm>
             <a:off x="502920" y="1517904"/>
-            <a:ext cx="411480" cy="411480"/>
+            <a:ext cx="411480" cy="1003554"/>
           </a:xfrm>
           <a:prstGeom prst="rect">
             <a:avLst/>
@@ -10365,7 +10365,7 @@
           <a:noFill/>
         </p:spPr>
         <p:txBody>
-          <a:bodyPr wrap="square" lIns="0" rIns="0" tIns="0" bIns="0" anchor="t">
+          <a:bodyPr wrap="square" lIns="0" rIns="0" tIns="0" bIns="0" anchor="ctr">
             <a:noAutofit/>
           </a:bodyPr>
           <a:lstStyle/>
@@ -10404,7 +10404,7 @@
           <a:noFill/>
         </p:spPr>
         <p:txBody>
-          <a:bodyPr wrap="square" lIns="0" rIns="0" tIns="0" bIns="0" anchor="t">
+          <a:bodyPr wrap="square" lIns="0" rIns="0" tIns="0" bIns="0" anchor="ctr">
             <a:noAutofit/>
           </a:bodyPr>
           <a:lstStyle/>
@@ -10443,7 +10443,7 @@
           <a:noFill/>
         </p:spPr>
         <p:txBody>
-          <a:bodyPr wrap="square" lIns="0" rIns="0" tIns="0" bIns="0" anchor="t">
+          <a:bodyPr wrap="square" lIns="0" rIns="0" tIns="0" bIns="0" anchor="ctr">
             <a:noAutofit/>
           </a:bodyPr>
           <a:lstStyle/>
@@ -10495,7 +10495,7 @@
         <p:spPr>
           <a:xfrm>
             <a:off x="502920" y="2731770"/>
-            <a:ext cx="411480" cy="411480"/>
+            <a:ext cx="411480" cy="1003554"/>
           </a:xfrm>
           <a:prstGeom prst="rect">
             <a:avLst/>
@@ -10503,7 +10503,7 @@
           <a:noFill/>
         </p:spPr>
         <p:txBody>
-          <a:bodyPr wrap="square" lIns="0" rIns="0" tIns="0" bIns="0" anchor="t">
+          <a:bodyPr wrap="square" lIns="0" rIns="0" tIns="0" bIns="0" anchor="ctr">
             <a:noAutofit/>
           </a:bodyPr>
           <a:lstStyle/>
@@ -10542,7 +10542,7 @@
           <a:noFill/>
         </p:spPr>
         <p:txBody>
-          <a:bodyPr wrap="square" lIns="0" rIns="0" tIns="0" bIns="0" anchor="t">
+          <a:bodyPr wrap="square" lIns="0" rIns="0" tIns="0" bIns="0" anchor="ctr">
             <a:noAutofit/>
           </a:bodyPr>
           <a:lstStyle/>
@@ -10581,7 +10581,7 @@
           <a:noFill/>
         </p:spPr>
         <p:txBody>
-          <a:bodyPr wrap="square" lIns="0" rIns="0" tIns="0" bIns="0" anchor="t">
+          <a:bodyPr wrap="square" lIns="0" rIns="0" tIns="0" bIns="0" anchor="ctr">
             <a:noAutofit/>
           </a:bodyPr>
           <a:lstStyle/>
@@ -10633,7 +10633,7 @@
         <p:spPr>
           <a:xfrm>
             <a:off x="502920" y="3945636"/>
-            <a:ext cx="411480" cy="411480"/>
+            <a:ext cx="411480" cy="1003554"/>
           </a:xfrm>
           <a:prstGeom prst="rect">
             <a:avLst/>
@@ -10641,7 +10641,7 @@
           <a:noFill/>
         </p:spPr>
         <p:txBody>
-          <a:bodyPr wrap="square" lIns="0" rIns="0" tIns="0" bIns="0" anchor="t">
+          <a:bodyPr wrap="square" lIns="0" rIns="0" tIns="0" bIns="0" anchor="ctr">
             <a:noAutofit/>
           </a:bodyPr>
           <a:lstStyle/>
@@ -10680,7 +10680,7 @@
           <a:noFill/>
         </p:spPr>
         <p:txBody>
-          <a:bodyPr wrap="square" lIns="0" rIns="0" tIns="0" bIns="0" anchor="t">
+          <a:bodyPr wrap="square" lIns="0" rIns="0" tIns="0" bIns="0" anchor="ctr">
             <a:noAutofit/>
           </a:bodyPr>
           <a:lstStyle/>
@@ -10719,7 +10719,7 @@
           <a:noFill/>
         </p:spPr>
         <p:txBody>
-          <a:bodyPr wrap="square" lIns="0" rIns="0" tIns="0" bIns="0" anchor="t">
+          <a:bodyPr wrap="square" lIns="0" rIns="0" tIns="0" bIns="0" anchor="ctr">
             <a:noAutofit/>
           </a:bodyPr>
           <a:lstStyle/>
@@ -10771,7 +10771,7 @@
         <p:spPr>
           <a:xfrm>
             <a:off x="502920" y="5159502"/>
-            <a:ext cx="411480" cy="411480"/>
+            <a:ext cx="411480" cy="1003554"/>
           </a:xfrm>
           <a:prstGeom prst="rect">
             <a:avLst/>
@@ -10779,7 +10779,7 @@
           <a:noFill/>
         </p:spPr>
         <p:txBody>
-          <a:bodyPr wrap="square" lIns="0" rIns="0" tIns="0" bIns="0" anchor="t">
+          <a:bodyPr wrap="square" lIns="0" rIns="0" tIns="0" bIns="0" anchor="ctr">
             <a:noAutofit/>
           </a:bodyPr>
           <a:lstStyle/>
@@ -10818,7 +10818,7 @@
           <a:noFill/>
         </p:spPr>
         <p:txBody>
-          <a:bodyPr wrap="square" lIns="0" rIns="0" tIns="0" bIns="0" anchor="t">
+          <a:bodyPr wrap="square" lIns="0" rIns="0" tIns="0" bIns="0" anchor="ctr">
             <a:noAutofit/>
           </a:bodyPr>
           <a:lstStyle/>
@@ -10857,7 +10857,7 @@
           <a:noFill/>
         </p:spPr>
         <p:txBody>
-          <a:bodyPr wrap="square" lIns="0" rIns="0" tIns="0" bIns="0" anchor="t">
+          <a:bodyPr wrap="square" lIns="0" rIns="0" tIns="0" bIns="0" anchor="ctr">
             <a:noAutofit/>
           </a:bodyPr>
           <a:lstStyle/>

</xml_diff>

<commit_message>
v1.3.3: balanced cover with measured title block and footer band
Co-Authored-By: Claude Opus 5.5 <noreply@anthropic.com>
Claude-Session: https://claude.ai/code/session_01Rvc9GtWhuPc2Bv8Fiv99q3
</commit_message>
<xml_diff>
--- a/examples/alvora/output/1_draft/deck.pptx
+++ b/examples/alvora/output/1_draft/deck.pptx
@@ -6240,7 +6240,7 @@
         </p:nvSpPr>
         <p:spPr>
           <a:xfrm>
-            <a:off x="502920" y="2148840"/>
+            <a:off x="502920" y="2384984"/>
             <a:ext cx="822960" cy="64008"/>
           </a:xfrm>
           <a:prstGeom prst="rect">
@@ -6269,8 +6269,8 @@
         </p:nvSpPr>
         <p:spPr>
           <a:xfrm>
-            <a:off x="502920" y="2377440"/>
-            <a:ext cx="9288018" cy="1737360"/>
+            <a:off x="502920" y="2677592"/>
+            <a:ext cx="9288018" cy="626364"/>
           </a:xfrm>
           <a:prstGeom prst="rect">
             <a:avLst/>
@@ -6308,8 +6308,8 @@
         </p:nvSpPr>
         <p:spPr>
           <a:xfrm>
-            <a:off x="502920" y="4160520"/>
-            <a:ext cx="8339099" cy="822960"/>
+            <a:off x="502920" y="3505124"/>
+            <a:ext cx="8339099" cy="329184"/>
           </a:xfrm>
           <a:prstGeom prst="rect">
             <a:avLst/>
@@ -6341,13 +6341,42 @@
       </p:sp>
       <p:sp>
         <p:nvSpPr>
-          <p:cNvPr id="5" name="cpe|text|text|4"/>
+          <p:cNvPr id="5" name="cpe|text|bleed|4"/>
+          <p:cNvSpPr/>
+          <p:nvPr/>
+        </p:nvSpPr>
+        <p:spPr>
+          <a:xfrm>
+            <a:off x="0" y="5486400"/>
+            <a:ext cx="12191695" cy="1371600"/>
+          </a:xfrm>
+          <a:prstGeom prst="rect">
+            <a:avLst/>
+          </a:prstGeom>
+          <a:solidFill>
+            <a:srgbClr val="0B1F3A"/>
+          </a:solidFill>
+          <a:ln>
+            <a:noFill/>
+          </a:ln>
+        </p:spPr>
+        <p:txBody>
+          <a:bodyPr rtlCol="0" anchor="ctr" lIns="0" rIns="0" tIns="0" bIns="0"/>
+          <a:lstStyle/>
+          <a:p>
+            <a:pPr algn="ctr"/>
+          </a:p>
+        </p:txBody>
+      </p:sp>
+      <p:sp>
+        <p:nvSpPr>
+          <p:cNvPr id="6" name="cpe|text|text|5"/>
           <p:cNvSpPr txBox="1"/>
           <p:nvPr/>
         </p:nvSpPr>
         <p:spPr>
           <a:xfrm>
-            <a:off x="502920" y="5989320"/>
+            <a:off x="502920" y="6012180"/>
             <a:ext cx="8339099" cy="320040"/>
           </a:xfrm>
           <a:prstGeom prst="rect">
@@ -6356,7 +6385,7 @@
           <a:noFill/>
         </p:spPr>
         <p:txBody>
-          <a:bodyPr wrap="square" lIns="0" rIns="0" tIns="0" bIns="0" anchor="t">
+          <a:bodyPr wrap="square" lIns="0" rIns="0" tIns="0" bIns="0" anchor="ctr">
             <a:noAutofit/>
           </a:bodyPr>
           <a:lstStyle/>
@@ -6367,9 +6396,9 @@
               </a:lnSpc>
             </a:pPr>
             <a:r>
-              <a:rPr sz="1000" b="0">
-                <a:solidFill>
-                  <a:srgbClr val="5E6A77"/>
+              <a:rPr sz="1100" b="0">
+                <a:solidFill>
+                  <a:srgbClr val="FFFFFF"/>
                 </a:solidFill>
                 <a:latin typeface="Arial"/>
               </a:rPr>

</xml_diff>